<commit_message>
Vorlage: aktuelles C-Logo, Zusatzfarben (Website-Grafiken), Boxhöhen, Website-Grafiken in Beispielfolien
- altes C (Punktring) entfernt, neues C aus der Wortmarke als SVG/PNG unter /marke/
- Zusatzfarben in ci/SKILL.md, ci/tokens.json (colorExtra) und als benutzerdefinierte Farben im PowerPoint-Theme
- vier aktuelle Website-Grafiken als echte Formen in der Beispielpräsentation

Co-Authored-By: Claude Opus 5.5 <noreply@anthropic.com>
Claude-Session: https://claude.ai/code/session_013CPr38Ajq4U6Bb9Du7X7Xh
</commit_message>
<xml_diff>
--- a/vorlagen/CASI-Folien.pptx
+++ b/vorlagen/CASI-Folien.pptx
@@ -650,7 +650,7 @@
         <p:spPr>
           <a:xfrm>
             <a:off x="612648" y="493776"/>
-            <a:ext cx="450952" cy="502920"/>
+            <a:ext cx="448856" cy="502920"/>
           </a:xfrm>
           <a:prstGeom prst="rect">
             <a:avLst/>
@@ -824,7 +824,7 @@
         <p:spPr>
           <a:xfrm>
             <a:off x="612648" y="6437376"/>
-            <a:ext cx="163982" cy="182880"/>
+            <a:ext cx="163220" cy="182880"/>
           </a:xfrm>
           <a:prstGeom prst="rect">
             <a:avLst/>
@@ -928,7 +928,7 @@
         <p:spPr>
           <a:xfrm>
             <a:off x="612648" y="493776"/>
-            <a:ext cx="450952" cy="502920"/>
+            <a:ext cx="448856" cy="502920"/>
           </a:xfrm>
           <a:prstGeom prst="rect">
             <a:avLst/>
@@ -1220,7 +1220,7 @@
         <p:spPr>
           <a:xfrm>
             <a:off x="612648" y="6437376"/>
-            <a:ext cx="163982" cy="182880"/>
+            <a:ext cx="163220" cy="182880"/>
           </a:xfrm>
           <a:prstGeom prst="rect">
             <a:avLst/>
@@ -1442,7 +1442,7 @@
         <p:spPr>
           <a:xfrm>
             <a:off x="612648" y="6437376"/>
-            <a:ext cx="163982" cy="182880"/>
+            <a:ext cx="163220" cy="182880"/>
           </a:xfrm>
           <a:prstGeom prst="rect">
             <a:avLst/>
@@ -1664,7 +1664,7 @@
         <p:spPr>
           <a:xfrm>
             <a:off x="612648" y="6437376"/>
-            <a:ext cx="163982" cy="182880"/>
+            <a:ext cx="163220" cy="182880"/>
           </a:xfrm>
           <a:prstGeom prst="rect">
             <a:avLst/>
@@ -1821,7 +1821,7 @@
         <p:spPr>
           <a:xfrm>
             <a:off x="612648" y="6437376"/>
-            <a:ext cx="163982" cy="182880"/>
+            <a:ext cx="163220" cy="182880"/>
           </a:xfrm>
           <a:prstGeom prst="rect">
             <a:avLst/>
@@ -2108,7 +2108,7 @@
         <p:spPr>
           <a:xfrm>
             <a:off x="612648" y="6437376"/>
-            <a:ext cx="163982" cy="182880"/>
+            <a:ext cx="163220" cy="182880"/>
           </a:xfrm>
           <a:prstGeom prst="rect">
             <a:avLst/>
@@ -2403,7 +2403,7 @@
         <p:spPr>
           <a:xfrm>
             <a:off x="612648" y="6437376"/>
-            <a:ext cx="163982" cy="182880"/>
+            <a:ext cx="163220" cy="182880"/>
           </a:xfrm>
           <a:prstGeom prst="rect">
             <a:avLst/>
@@ -2706,7 +2706,7 @@
         <p:spPr>
           <a:xfrm>
             <a:off x="612648" y="6437376"/>
-            <a:ext cx="163982" cy="182880"/>
+            <a:ext cx="163220" cy="182880"/>
           </a:xfrm>
           <a:prstGeom prst="rect">
             <a:avLst/>
@@ -3707,6 +3707,68 @@
   </a:themeElements>
   <a:objectDefaults/>
   <a:extraClrSchemeLst/>
+  <a:custClrLst>
+    <a:custClr name="ICCA">
+      <a:srgbClr val="13917C"/>
+    </a:custClr>
+    <a:custClr name="ICCA Grafik">
+      <a:srgbClr val="1A9C7E"/>
+    </a:custClr>
+    <a:custClr name="Burgundy hell">
+      <a:srgbClr val="F6EBEF"/>
+    </a:custClr>
+    <a:custClr name="Burgundy mittel">
+      <a:srgbClr val="CB96A6"/>
+    </a:custClr>
+    <a:custClr name="Kette direct">
+      <a:srgbClr val="29363D"/>
+    </a:custClr>
+    <a:custClr name="Kette iron">
+      <a:srgbClr val="8C5A3C"/>
+    </a:custClr>
+    <a:custClr name="Kette steel">
+      <a:srgbClr val="5B7C99"/>
+    </a:custClr>
+    <a:custClr name="Kette car">
+      <a:srgbClr val="3F6B3F"/>
+    </a:custClr>
+    <a:custClr name="Kette body">
+      <a:srgbClr val="0E8388"/>
+    </a:custClr>
+    <a:custClr name="Kette Lebensende">
+      <a:srgbClr val="6B4C6E"/>
+    </a:custClr>
+    <a:custClr name="Daten A">
+      <a:srgbClr val="B060E0"/>
+    </a:custClr>
+    <a:custClr name="Daten B">
+      <a:srgbClr val="3060C0"/>
+    </a:custClr>
+    <a:custClr name="Daten C">
+      <a:srgbClr val="2080B0"/>
+    </a:custClr>
+    <a:custClr name="Daten D">
+      <a:srgbClr val="50B0D0"/>
+    </a:custClr>
+    <a:custClr name="Daten E">
+      <a:srgbClr val="20C090"/>
+    </a:custClr>
+    <a:custClr name="Daten F">
+      <a:srgbClr val="30A060"/>
+    </a:custClr>
+    <a:custClr name="Daten G">
+      <a:srgbClr val="E08820"/>
+    </a:custClr>
+    <a:custClr name="Daten H">
+      <a:srgbClr val="D06020"/>
+    </a:custClr>
+    <a:custClr name="Daten I">
+      <a:srgbClr val="E04040"/>
+    </a:custClr>
+    <a:custClr name="Daten J">
+      <a:srgbClr val="C04080"/>
+    </a:custClr>
+  </a:custClrLst>
   <a:extLst>
     <a:ext uri="{05A4C25C-085E-4340-85A3-A5531E510DB2}">
       <thm15:themeFamily xmlns:thm15="http://schemas.microsoft.com/office/thememl/2012/main" name="Office Theme" id="{62F939B6-93AF-4DB8-9C6B-D6C7DFDC589F}" vid="{4A3C46E8-61CC-4603-A589-7422A47A8E4A}"/>

</xml_diff>